<commit_message>
Refocus deck on customer migration conversation
</commit_message>
<xml_diff>
--- a/demo-assets/output/Fabric_Migration_Readiness_Assistant_Hackathon_Deck.pptx
+++ b/demo-assets/output/Fabric_Migration_Readiness_Assistant_Hackathon_Deck.pptx
@@ -509,7 +509,7 @@
           <a:lstStyle/>
           <a:p>
             <a:r>
-              <a:t>Introduce the prototype and the outcome: a repeatable Fabric migration assessment.</a:t>
+              <a:t>Open with the engagement outcome: help a CSA start the right migration conversation before architecture and sizing decisions are made.</a:t>
             </a:r>
           </a:p>
         </p:txBody>
@@ -579,7 +579,7 @@
           <a:lstStyle/>
           <a:p>
             <a:r>
-              <a:t>Explain the fragmented estate and why ad hoc assessment is slow and inconsistent.</a:t>
+              <a:t>Explain why the initial conversation is difficult: fragmented workloads, premature sizing, and redesign needs that surface too late.</a:t>
             </a:r>
           </a:p>
         </p:txBody>
@@ -649,7 +649,7 @@
           <a:lstStyle/>
           <a:p>
             <a:r>
-              <a:t>Show the three supported intake routes and the governed assessment flow.</a:t>
+              <a:t>Name the primary user and collaborators: the CSA leads, customer leaders set outcomes, technical teams confirm facts, and sponsors consume the recommendation.</a:t>
             </a:r>
           </a:p>
         </p:txBody>
@@ -719,7 +719,7 @@
           <a:lstStyle/>
           <a:p>
             <a:r>
-              <a:t>The discovery screen captures business context and measurable workload pressure.</a:t>
+              <a:t>Show how the assistant supports the engagement before, during, and after the customer conversation while keeping unknowns explicit.</a:t>
             </a:r>
           </a:p>
         </p:txBody>
@@ -789,7 +789,7 @@
           <a:lstStyle/>
           <a:p>
             <a:r>
-              <a:t>Spreadsheet inventory is saved as CSV for browser upload; PDF uses Copilot or CLI; manual entry is available.</a:t>
+              <a:t>Explain that the assessment goes beyond mapping: it tests blockers, required design changes, optimisation opportunities, and capacity pressure.</a:t>
             </a:r>
           </a:p>
         </p:txBody>
@@ -859,7 +859,7 @@
           <a:lstStyle/>
           <a:p>
             <a:r>
-              <a:t>The engine maps workloads and explains blockers, optimisation actions, and open questions.</a:t>
+              <a:t>Describe the customer-ready output and reinforce that SKU data is directional estimator input, not a capacity quote.</a:t>
             </a:r>
           </a:p>
         </p:txBody>
@@ -929,7 +929,7 @@
           <a:lstStyle/>
           <a:p>
             <a:r>
-              <a:t>The summary is customer-ready and includes directional inputs for the SKU Estimator, not a capacity quote.</a:t>
+              <a:t>Position the solution as a maintained skill with versioned deterministic rules, current Microsoft Learn evidence, specialist skills, and engagement feedback.</a:t>
             </a:r>
           </a:p>
         </p:txBody>
@@ -999,7 +999,7 @@
           <a:lstStyle/>
           <a:p>
             <a:r>
-              <a:t>Close on impact and the path from hackathon prototype to a validated engagement tool.</a:t>
+              <a:t>Close on the value to the CSA, customer, delivery team, and Fabric conversation; ask to pilot it on real customer estates.</a:t>
             </a:r>
           </a:p>
         </p:txBody>

</xml_diff>